<commit_message>
docs(m10): remove closing slide — deck now ends on Results (13 slides)
</commit_message>
<xml_diff>
--- a/StockDesk_DevOps_Capstone.pptx
+++ b/StockDesk_DevOps_Capstone.pptx
@@ -18,10 +18,9 @@
     <p:sldId id="266" r:id="rId12"/>
     <p:sldId id="267" r:id="rId13"/>
     <p:sldId id="268" r:id="rId14"/>
-    <p:sldId id="269" r:id="rId15"/>
   </p:sldIdLst>
   <p:notesMasterIdLst>
-    <p:notesMasterId r:id="rId16"/>
+    <p:notesMasterId r:id="rId15"/>
   </p:notesMasterIdLst>
   <p:sldSz cx="12192000" cy="6858000"/>
   <p:notesSz cx="6858000" cy="12192000"/>
@@ -120,62 +119,57 @@
   <p:extLst>
     <p:ext uri="{521415D9-36F7-43E2-AB2F-B90AF26B5E84}">
       <p14:sectionLst xmlns:p14="http://schemas.microsoft.com/office/powerpoint/2010/main">
-        <p14:section name="Intro" id="{04984ecf-a4fc-f23a-333f-7eb57a1e7e20}">
+        <p14:section name="Intro" id="{2bd46758-7d83-0367-4a99-38e522f5c3d8}">
           <p14:sldIdLst>
             <p14:sldId id="256"/>
           </p14:sldIdLst>
         </p14:section>
-        <p14:section name="Overview" id="{8f79db12-a2b5-3f38-44ff-d8439d791dd7}">
+        <p14:section name="Overview" id="{14ad2510-e885-1ff4-2ed5-31978a247922}">
           <p14:sldIdLst>
             <p14:sldId id="257"/>
             <p14:sldId id="259"/>
           </p14:sldIdLst>
         </p14:section>
-        <p14:section name="Architecture" id="{f54112de-1811-13aa-45d0-c484006d51a9}">
+        <p14:section name="Architecture" id="{8cb22f67-03bc-552b-223b-c6fe4b3af2ab}">
           <p14:sldIdLst>
             <p14:sldId id="258"/>
           </p14:sldIdLst>
         </p14:section>
-        <p14:section name="Application" id="{81f53874-e8d3-df0e-a34a-73055ca1fb36}">
+        <p14:section name="Application" id="{5d0f8721-87ef-c64a-f44d-8e62751e3f2c}">
           <p14:sldIdLst>
             <p14:sldId id="260"/>
           </p14:sldIdLst>
         </p14:section>
-        <p14:section name="Build &amp; Ship" id="{7a640178-f0d2-8398-a313-50eab55fb6f9}">
+        <p14:section name="Build &amp; Ship" id="{97f0cad1-90eb-eb92-1c49-e4233a37637f}">
           <p14:sldIdLst>
             <p14:sldId id="261"/>
             <p14:sldId id="262"/>
           </p14:sldIdLst>
         </p14:section>
-        <p14:section name="Security" id="{04934f06-401d-2082-3684-15ff33cd740c}">
+        <p14:section name="Security" id="{3538a434-d071-1a51-014b-6d83eb9c02e2}">
           <p14:sldIdLst>
             <p14:sldId id="263"/>
           </p14:sldIdLst>
         </p14:section>
-        <p14:section name="Infrastructure" id="{ac262668-8425-50fd-4882-05b0b99f6327}">
+        <p14:section name="Infrastructure" id="{2919b453-74c7-7430-7d99-476f92a3a569}">
           <p14:sldIdLst>
             <p14:sldId id="264"/>
             <p14:sldId id="265"/>
           </p14:sldIdLst>
         </p14:section>
-        <p14:section name="Observability" id="{aede1c35-f4e4-1489-4d23-8b678907c0c2}">
+        <p14:section name="Observability" id="{a1aa2ab0-7328-67e0-f2df-0c4b8057f8e3}">
           <p14:sldIdLst>
             <p14:sldId id="266"/>
           </p14:sldIdLst>
         </p14:section>
-        <p14:section name="GitOps" id="{d6db428b-eb13-3bc0-b1d1-00c202d00ee8}">
+        <p14:section name="GitOps" id="{fcecba71-2349-c92d-2917-fcef1ad356ae}">
           <p14:sldIdLst>
             <p14:sldId id="267"/>
           </p14:sldIdLst>
         </p14:section>
-        <p14:section name="Results" id="{f163979e-f589-3ee0-5178-1e73b94328eb}">
+        <p14:section name="Results" id="{fc0787ae-5dea-5c85-8a28-65d33515ecbb}">
           <p14:sldIdLst>
             <p14:sldId id="268"/>
-          </p14:sldIdLst>
-        </p14:section>
-        <p14:section name="Close" id="{28ad12f4-83b3-2368-5e53-79e9eae1b57e}">
-          <p14:sldIdLst>
-            <p14:sldId id="269"/>
           </p14:sldIdLst>
         </p14:section>
       </p14:sectionLst>
@@ -958,94 +952,6 @@
             <a:fld id="{F7021451-1387-4CA6-816F-3879F97B5CBC}" type="slidenum">
               <a:rPr lang="en-US"/>
               <a:t>13</a:t>
-            </a:fld>
-            <a:endParaRPr lang="en-US"/>
-          </a:p>
-        </p:txBody>
-      </p:sp>
-    </p:spTree>
-    <p:extLst>
-      <p:ext uri="{BB962C8B-B14F-4D97-AF65-F5344CB8AC3E}">
-        <p14:creationId xmlns:p14="http://schemas.microsoft.com/office/powerpoint/2010/main" val="1024086991"/>
-      </p:ext>
-    </p:extLst>
-  </p:cSld>
-  <p:clrMapOvr>
-    <a:masterClrMapping/>
-  </p:clrMapOvr>
-</p:notes>
-</file>
-
-<file path=ppt/notesSlides/notesSlide14.xml><?xml version="1.0" encoding="utf-8"?>
-<p:notes xmlns:a="http://schemas.openxmlformats.org/drawingml/2006/main" xmlns:r="http://schemas.openxmlformats.org/officeDocument/2006/relationships" xmlns:p="http://schemas.openxmlformats.org/presentationml/2006/main">
-  <p:cSld>
-    <p:spTree>
-      <p:nvGrpSpPr>
-        <p:cNvPr id="1" name=""/>
-        <p:cNvGrpSpPr/>
-        <p:nvPr/>
-      </p:nvGrpSpPr>
-      <p:grpSpPr>
-        <a:xfrm>
-          <a:off x="0" y="0"/>
-          <a:ext cx="0" cy="0"/>
-          <a:chOff x="0" y="0"/>
-          <a:chExt cx="0" cy="0"/>
-        </a:xfrm>
-      </p:grpSpPr>
-      <p:sp>
-        <p:nvSpPr>
-          <p:cNvPr id="2" name="Slide Image Placeholder 1"/>
-          <p:cNvSpPr>
-            <a:spLocks noGrp="1" noRot="1" noChangeAspect="1"/>
-          </p:cNvSpPr>
-          <p:nvPr>
-            <p:ph type="sldImg"/>
-          </p:nvPr>
-        </p:nvSpPr>
-        <p:spPr/>
-      </p:sp>
-      <p:sp>
-        <p:nvSpPr>
-          <p:cNvPr id="3" name="Notes Placeholder 2"/>
-          <p:cNvSpPr>
-            <a:spLocks noGrp="1"/>
-          </p:cNvSpPr>
-          <p:nvPr>
-            <p:ph type="body" idx="1"/>
-          </p:nvPr>
-        </p:nvSpPr>
-        <p:spPr/>
-        <p:txBody>
-          <a:bodyPr/>
-          <a:lstStyle/>
-          <a:p>
-            <a:r>
-              <a:rPr lang="en-US" dirty="0"/>
-              <a:t>Full lifecycle delivered. The two fixes show that deploying for real surfaces issues tests never will. Thanks — happy to demo live.</a:t>
-            </a:r>
-            <a:endParaRPr lang="en-US" dirty="0"/>
-          </a:p>
-        </p:txBody>
-      </p:sp>
-      <p:sp>
-        <p:nvSpPr>
-          <p:cNvPr id="4" name="Slide Number Placeholder 3"/>
-          <p:cNvSpPr>
-            <a:spLocks noGrp="1"/>
-          </p:cNvSpPr>
-          <p:nvPr>
-            <p:ph type="sldNum" sz="quarter" idx="10"/>
-          </p:nvPr>
-        </p:nvSpPr>
-        <p:spPr/>
-        <p:txBody>
-          <a:bodyPr/>
-          <a:lstStyle/>
-          <a:p>
-            <a:fld id="{F7021451-1387-4CA6-816F-3879F97B5CBC}" type="slidenum">
-              <a:rPr lang="en-US"/>
-              <a:t>14</a:t>
             </a:fld>
             <a:endParaRPr lang="en-US"/>
           </a:p>
@@ -5033,262 +4939,6 @@
               <a:t>13</a:t>
             </a:fld>
             <a:endParaRPr lang="en-US"/>
-          </a:p>
-        </p:txBody>
-      </p:sp>
-    </p:spTree>
-  </p:cSld>
-  <p:clrMapOvr>
-    <a:masterClrMapping/>
-  </p:clrMapOvr>
-</p:sld>
-</file>
-
-<file path=ppt/slides/slide14.xml><?xml version="1.0" encoding="utf-8"?>
-<p:sld xmlns:a="http://schemas.openxmlformats.org/drawingml/2006/main" xmlns:r="http://schemas.openxmlformats.org/officeDocument/2006/relationships" xmlns:p="http://schemas.openxmlformats.org/presentationml/2006/main">
-  <p:cSld name="Slide 14">
-    <p:spTree>
-      <p:nvGrpSpPr>
-        <p:cNvPr id="1" name=""/>
-        <p:cNvGrpSpPr/>
-        <p:nvPr/>
-      </p:nvGrpSpPr>
-      <p:grpSpPr>
-        <a:xfrm>
-          <a:off x="0" y="0"/>
-          <a:ext cx="0" cy="0"/>
-          <a:chOff x="0" y="0"/>
-          <a:chExt cx="0" cy="0"/>
-        </a:xfrm>
-      </p:grpSpPr>
-      <p:sp>
-        <p:nvSpPr>
-          <p:cNvPr id="2" name="Text 0"/>
-          <p:cNvSpPr/>
-          <p:nvPr>
-            <p:ph hasCustomPrompt="1"/>
-          </p:nvPr>
-        </p:nvSpPr>
-        <p:spPr>
-          <a:xfrm>
-            <a:off x="731520" y="1463040"/>
-            <a:ext cx="10698480" cy="457200"/>
-          </a:xfrm>
-          <a:prstGeom prst="rect">
-            <a:avLst/>
-          </a:prstGeom>
-          <a:noFill/>
-          <a:ln/>
-        </p:spPr>
-        <p:txBody>
-          <a:bodyPr wrap="square" rtlCol="0"/>
-          <a:lstStyle/>
-          <a:p>
-            <a:pPr indent="0" marL="0">
-              <a:buNone/>
-            </a:pPr>
-            <a:r>
-              <a:rPr lang="en-US" dirty="0">
-                <a:solidFill>
-                  <a:srgbClr val="00A896"/>
-                </a:solidFill>
-              </a:rPr>
-              <a:t>CONCLUSION</a:t>
-            </a:r>
-            <a:endParaRPr lang="en-US" dirty="0"/>
-          </a:p>
-        </p:txBody>
-      </p:sp>
-      <p:sp>
-        <p:nvSpPr>
-          <p:cNvPr id="3" name="Text 1"/>
-          <p:cNvSpPr/>
-          <p:nvPr>
-            <p:ph hasCustomPrompt="1"/>
-          </p:nvPr>
-        </p:nvSpPr>
-        <p:spPr>
-          <a:xfrm>
-            <a:off x="731520" y="1920240"/>
-            <a:ext cx="10698480" cy="1097280"/>
-          </a:xfrm>
-          <a:prstGeom prst="rect">
-            <a:avLst/>
-          </a:prstGeom>
-          <a:noFill/>
-          <a:ln/>
-        </p:spPr>
-        <p:txBody>
-          <a:bodyPr wrap="square" rtlCol="0"/>
-          <a:lstStyle/>
-          <a:p>
-            <a:pPr indent="0" marL="0">
-              <a:buNone/>
-            </a:pPr>
-            <a:r>
-              <a:rPr lang="en-US" dirty="0">
-                <a:solidFill>
-                  <a:srgbClr val="FFFFFF"/>
-                </a:solidFill>
-              </a:rPr>
-              <a:t>From laptop to monitored production</a:t>
-            </a:r>
-            <a:endParaRPr lang="en-US" dirty="0"/>
-          </a:p>
-        </p:txBody>
-      </p:sp>
-      <p:sp>
-        <p:nvSpPr>
-          <p:cNvPr id="4" name="Text 2"/>
-          <p:cNvSpPr/>
-          <p:nvPr>
-            <p:ph hasCustomPrompt="1"/>
-          </p:nvPr>
-        </p:nvSpPr>
-        <p:spPr>
-          <a:xfrm>
-            <a:off x="749808" y="3108960"/>
-            <a:ext cx="10515600" cy="2926080"/>
-          </a:xfrm>
-          <a:prstGeom prst="rect">
-            <a:avLst/>
-          </a:prstGeom>
-          <a:noFill/>
-          <a:ln/>
-        </p:spPr>
-        <p:txBody>
-          <a:bodyPr wrap="square" rtlCol="0"/>
-          <a:lstStyle/>
-          <a:p>
-            <a:pPr indent="0" marL="0">
-              <a:spcAft>
-                <a:spcPts val="1400"/>
-              </a:spcAft>
-              <a:buNone/>
-            </a:pPr>
-            <a:r>
-              <a:rPr lang="en-US" dirty="0">
-                <a:solidFill>
-                  <a:srgbClr val="CADCFC"/>
-                </a:solidFill>
-              </a:rPr>
-              <a:t>A simple app carried through the full DevOps lifecycle: containers, tested CI/CD, DevSecOps scanning, Terraform-provisioned EKS, Helm, GitOps, and observability.</a:t>
-            </a:r>
-            <a:endParaRPr lang="en-US" dirty="0"/>
-          </a:p>
-          <a:p>
-            <a:pPr indent="0" marL="0">
-              <a:spcAft>
-                <a:spcPts val="600"/>
-              </a:spcAft>
-              <a:buNone/>
-            </a:pPr>
-            <a:r>
-              <a:rPr lang="en-US" b="1" dirty="0">
-                <a:solidFill>
-                  <a:srgbClr val="FFFFFF"/>
-                </a:solidFill>
-              </a:rPr>
-              <a:t>Real bugs found by actually deploying:</a:t>
-            </a:r>
-            <a:endParaRPr lang="en-US" dirty="0"/>
-          </a:p>
-          <a:p>
-            <a:pPr marL="342900" indent="-342900">
-              <a:buSzPct val="100000"/>
-              <a:buChar char="•"/>
-            </a:pPr>
-            <a:r>
-              <a:rPr lang="en-US" dirty="0">
-                <a:solidFill>
-                  <a:srgbClr val="CADCFC"/>
-                </a:solidFill>
-              </a:rPr>
-              <a:t>alembic prepend_sys_path — migrations couldn't import app in-container</a:t>
-            </a:r>
-            <a:endParaRPr lang="en-US" dirty="0"/>
-          </a:p>
-          <a:p>
-            <a:pPr marL="342900" indent="-342900">
-              <a:spcAft>
-                <a:spcPts val="1400"/>
-              </a:spcAft>
-              <a:buSzPct val="100000"/>
-              <a:buChar char="•"/>
-            </a:pPr>
-            <a:r>
-              <a:rPr lang="en-US" dirty="0">
-                <a:solidFill>
-                  <a:srgbClr val="CADCFC"/>
-                </a:solidFill>
-              </a:rPr>
-              <a:t>Postgres PGDATA subdir — initdb fails on an EBS volume's lost+found</a:t>
-            </a:r>
-            <a:endParaRPr lang="en-US" dirty="0"/>
-          </a:p>
-          <a:p>
-            <a:pPr indent="0" marL="0">
-              <a:buNone/>
-            </a:pPr>
-            <a:r>
-              <a:rPr lang="en-US" b="1" dirty="0">
-                <a:solidFill>
-                  <a:srgbClr val="00A896"/>
-                </a:solidFill>
-              </a:rPr>
-              <a:t>Demo:  loom.com/share/17e254cf0a774a64ac4bbb830a0a734e</a:t>
-            </a:r>
-            <a:endParaRPr lang="en-US" dirty="0"/>
-          </a:p>
-          <a:p>
-            <a:pPr indent="0" marL="0">
-              <a:buNone/>
-            </a:pPr>
-            <a:r>
-              <a:rPr lang="en-US" dirty="0">
-                <a:solidFill>
-                  <a:srgbClr val="CADCFC"/>
-                </a:solidFill>
-              </a:rPr>
-              <a:t>Repo:  github.com/Naren456/devops-project</a:t>
-            </a:r>
-            <a:endParaRPr lang="en-US" dirty="0"/>
-          </a:p>
-        </p:txBody>
-      </p:sp>
-      <p:sp>
-        <p:nvSpPr>
-          <p:cNvPr id="5" name="Text 3"/>
-          <p:cNvSpPr txBox="1"/>
-          <p:nvPr/>
-        </p:nvSpPr>
-        <p:spPr>
-          <a:xfrm>
-            <a:off x="731520" y="5989320"/>
-            <a:ext cx="10698480" cy="548640"/>
-          </a:xfrm>
-          <a:prstGeom prst="rect">
-            <a:avLst/>
-          </a:prstGeom>
-          <a:noFill/>
-          <a:ln/>
-        </p:spPr>
-        <p:txBody>
-          <a:bodyPr wrap="square" lIns="0" tIns="0" rIns="0" bIns="0" rtlCol="0" anchor="ctr"/>
-          <a:lstStyle/>
-          <a:p>
-            <a:pPr algn="l" indent="0" marL="0">
-              <a:buNone/>
-            </a:pPr>
-            <a:r>
-              <a:rPr lang="en-US" sz="2200" b="1" dirty="0">
-                <a:solidFill>
-                  <a:srgbClr val="FFFFFF"/>
-                </a:solidFill>
-              </a:rPr>
-              <a:t>Thank you</a:t>
-            </a:r>
-            <a:endParaRPr lang="en-US" sz="2200" dirty="0"/>
           </a:p>
         </p:txBody>
       </p:sp>

</xml_diff>